<commit_message>
maj produit à réapprovsionner
</commit_message>
<xml_diff>
--- a/presentation/AdventureWorks_Soutenance.pptx
+++ b/presentation/AdventureWorks_Soutenance.pptx
@@ -15532,7 +15532,7 @@
               <a:buNone/>
             </a:pPr>
             <a:r>
-              <a:rPr lang="en-US" sz="3200" b="1" i="0" dirty="0">
+              <a:rPr lang="en-US" sz="3200" b="1" i="0" dirty="0" err="1">
                 <a:solidFill>
                   <a:srgbClr val="1F2A2E"/>
                 </a:solidFill>
@@ -15540,7 +15540,18 @@
                 <a:ea typeface="Rubik" pitchFamily="34" charset="-122"/>
                 <a:cs typeface="Rubik" pitchFamily="34" charset="-120"/>
               </a:rPr>
-              <a:t>AdventureWorks 2025 : 15 tables, 3 domaines</a:t>
+              <a:t>AdventureWorks</a:t>
+            </a:r>
+            <a:r>
+              <a:rPr lang="en-US" sz="3200" b="1" i="0" dirty="0">
+                <a:solidFill>
+                  <a:srgbClr val="1F2A2E"/>
+                </a:solidFill>
+                <a:latin typeface="Rubik" pitchFamily="34" charset="0"/>
+                <a:ea typeface="Rubik" pitchFamily="34" charset="-122"/>
+                <a:cs typeface="Rubik" pitchFamily="34" charset="-120"/>
+              </a:rPr>
+              <a:t> 2025 : 15 tables, 3 domaines</a:t>
             </a:r>
             <a:endParaRPr lang="en-US" sz="3200" dirty="0"/>
           </a:p>
@@ -17536,7 +17547,7 @@
                 <a:ea typeface="IBM Plex Sans" pitchFamily="34" charset="-122"/>
                 <a:cs typeface="IBM Plex Sans" pitchFamily="34" charset="-120"/>
               </a:rPr>
-              <a:t>13 tables, DAX, 4 pages</a:t>
+              <a:t>15 tables, DAX, 4 pages</a:t>
             </a:r>
           </a:p>
         </p:txBody>

</xml_diff>